<commit_message>
Style B deck: remove footer text
Co-Authored-By: Claude Opus 5.5 <noreply@anthropic.com>
Claude-Session: https://claude.ai/code/session_01Pzs8XiFmXDfyH2owLp5tnZ
</commit_message>
<xml_diff>
--- a/Vorl_2/slides/lecture2-style-B.pptx
+++ b/Vorl_2/slides/lecture2-style-B.pptx
@@ -137,13 +137,13 @@
   <p:extLst>
     <p:ext uri="{521415D9-36F7-43E2-AB2F-B90AF26B5E84}">
       <p14:sectionLst xmlns:p14="http://schemas.microsoft.com/office/powerpoint/2010/main">
-        <p14:section name="Opening" id="{32ef97f3-c670-5141-b806-950a2eb3b0a0}">
+        <p14:section name="Opening" id="{1a004be6-2fd6-b06f-a0ab-15be5a1caadc}">
           <p14:sldIdLst>
             <p14:sldId id="256"/>
             <p14:sldId id="257"/>
           </p14:sldIdLst>
         </p14:section>
-        <p14:section name="Paper 1" id="{cf012760-16aa-aa46-a057-75098f840838}">
+        <p14:section name="Paper 1" id="{388f2aca-ca81-15fd-513a-8a5d519a775b}">
           <p14:sldIdLst>
             <p14:sldId id="258"/>
             <p14:sldId id="259"/>
@@ -157,7 +157,7 @@
             <p14:sldId id="267"/>
           </p14:sldIdLst>
         </p14:section>
-        <p14:section name="Paper 2" id="{25041ae3-4e37-254e-70c3-ca30288f845c}">
+        <p14:section name="Paper 2" id="{c873cca1-eec6-1ad6-fba6-6597845128ea}">
           <p14:sldIdLst>
             <p14:sldId id="268"/>
             <p14:sldId id="269"/>
@@ -171,7 +171,7 @@
             <p14:sldId id="277"/>
           </p14:sldIdLst>
         </p14:section>
-        <p14:section name="Cross Comparison" id="{9e1215ad-b6b7-33d9-d689-049e2a799ce1}">
+        <p14:section name="Cross Comparison" id="{00678f4c-f69d-7d58-8653-1547f1ca7d91}">
           <p14:sldIdLst>
             <p14:sldId id="278"/>
             <p14:sldId id="279"/>
@@ -180,14 +180,14 @@
             <p14:sldId id="282"/>
           </p14:sldIdLst>
         </p14:section>
-        <p14:section name="Criticism" id="{ebf04185-6457-c658-a734-92b5cd8c9186}">
+        <p14:section name="Criticism" id="{8f752d6b-b43d-f2b6-3321-1dcb30d99311}">
           <p14:sldIdLst>
             <p14:sldId id="283"/>
             <p14:sldId id="284"/>
             <p14:sldId id="285"/>
           </p14:sldIdLst>
         </p14:section>
-        <p14:section name="Close" id="{b4900a08-eb11-4f4f-4304-954fc19e6082}">
+        <p14:section name="Close" id="{e6b2780b-1f29-c60e-c03b-7c33c62c080f}">
           <p14:sldIdLst>
             <p14:sldId id="286"/>
           </p14:sldIdLst>
@@ -3332,45 +3332,6 @@
           <a:chExt cx="0" cy="0"/>
         </a:xfrm>
       </p:grpSpPr>
-      <p:sp>
-        <p:nvSpPr>
-          <p:cNvPr id="2" name="Text 0"/>
-          <p:cNvSpPr/>
-          <p:nvPr/>
-        </p:nvSpPr>
-        <p:spPr>
-          <a:xfrm>
-            <a:off x="640080" y="6355080"/>
-            <a:ext cx="5486400" cy="320040"/>
-          </a:xfrm>
-          <a:prstGeom prst="rect">
-            <a:avLst/>
-          </a:prstGeom>
-          <a:noFill/>
-          <a:ln/>
-        </p:spPr>
-        <p:txBody>
-          <a:bodyPr wrap="square" rtlCol="0" anchor="ctr"/>
-          <a:lstStyle/>
-          <a:p>
-            <a:pPr indent="0" marL="0">
-              <a:buNone/>
-            </a:pPr>
-            <a:r>
-              <a:rPr lang="en-US" sz="1100" dirty="0">
-                <a:solidFill>
-                  <a:srgbClr val="5F6368"/>
-                </a:solidFill>
-                <a:latin typeface="Arial" pitchFamily="34" charset="0"/>
-                <a:ea typeface="Arial" pitchFamily="34" charset="-122"/>
-                <a:cs typeface="Arial" pitchFamily="34" charset="-120"/>
-              </a:rPr>
-              <a:t>Lecture 2 · Artifact evaluation</a:t>
-            </a:r>
-            <a:endParaRPr lang="en-US" sz="1100" dirty="0"/>
-          </a:p>
-        </p:txBody>
-      </p:sp>
       <p:sp>
         <p:nvSpPr>
           <p:cNvPr id="25" name="Slide Number Placeholder 0"/>

</xml_diff>

<commit_message>
Style B deck: add open-floor slide before closing
Co-Authored-By: Claude Opus 5.5 <noreply@anthropic.com>
Claude-Session: https://claude.ai/code/session_01Pzs8XiFmXDfyH2owLp5tnZ
</commit_message>
<xml_diff>
--- a/Vorl_2/slides/lecture2-style-B.pptx
+++ b/Vorl_2/slides/lecture2-style-B.pptx
@@ -36,9 +36,10 @@
     <p:sldId id="284" r:id="rId30"/>
     <p:sldId id="285" r:id="rId31"/>
     <p:sldId id="286" r:id="rId32"/>
+    <p:sldId id="287" r:id="rId33"/>
   </p:sldIdLst>
   <p:notesMasterIdLst>
-    <p:notesMasterId r:id="rId33"/>
+    <p:notesMasterId r:id="rId34"/>
   </p:notesMasterIdLst>
   <p:sldSz cx="12192000" cy="6858000"/>
   <p:notesSz cx="6858000" cy="12192000"/>
@@ -137,13 +138,13 @@
   <p:extLst>
     <p:ext uri="{521415D9-36F7-43E2-AB2F-B90AF26B5E84}">
       <p14:sectionLst xmlns:p14="http://schemas.microsoft.com/office/powerpoint/2010/main">
-        <p14:section name="Opening" id="{1a004be6-2fd6-b06f-a0ab-15be5a1caadc}">
+        <p14:section name="Opening" id="{35b3c181-067d-9381-cbc0-2442e83121d4}">
           <p14:sldIdLst>
             <p14:sldId id="256"/>
             <p14:sldId id="257"/>
           </p14:sldIdLst>
         </p14:section>
-        <p14:section name="Paper 1" id="{388f2aca-ca81-15fd-513a-8a5d519a775b}">
+        <p14:section name="Paper 1" id="{56efa8ff-466a-346c-a957-d1c81ef4f9d3}">
           <p14:sldIdLst>
             <p14:sldId id="258"/>
             <p14:sldId id="259"/>
@@ -157,7 +158,7 @@
             <p14:sldId id="267"/>
           </p14:sldIdLst>
         </p14:section>
-        <p14:section name="Paper 2" id="{c873cca1-eec6-1ad6-fba6-6597845128ea}">
+        <p14:section name="Paper 2" id="{d2031bb7-b1b7-9827-98a5-f5fca2c947b4}">
           <p14:sldIdLst>
             <p14:sldId id="268"/>
             <p14:sldId id="269"/>
@@ -171,7 +172,7 @@
             <p14:sldId id="277"/>
           </p14:sldIdLst>
         </p14:section>
-        <p14:section name="Cross Comparison" id="{00678f4c-f69d-7d58-8653-1547f1ca7d91}">
+        <p14:section name="Cross Comparison" id="{3f1278c2-e357-14fa-5185-d1803fdf6fd7}">
           <p14:sldIdLst>
             <p14:sldId id="278"/>
             <p14:sldId id="279"/>
@@ -180,16 +181,17 @@
             <p14:sldId id="282"/>
           </p14:sldIdLst>
         </p14:section>
-        <p14:section name="Criticism" id="{8f752d6b-b43d-f2b6-3321-1dcb30d99311}">
+        <p14:section name="Criticism" id="{2ec8026e-be16-fd98-cd7e-cea994998717}">
           <p14:sldIdLst>
             <p14:sldId id="283"/>
             <p14:sldId id="284"/>
             <p14:sldId id="285"/>
+            <p14:sldId id="286"/>
           </p14:sldIdLst>
         </p14:section>
-        <p14:section name="Close" id="{e6b2780b-1f29-c60e-c03b-7c33c62c080f}">
+        <p14:section name="Close" id="{63870e26-e9cc-0141-5064-99d5d19450e0}">
           <p14:sldIdLst>
-            <p14:sldId id="286"/>
+            <p14:sldId id="287"/>
           </p14:sldIdLst>
         </p14:section>
       </p14:sectionLst>
@@ -2708,7 +2710,7 @@
           <a:p>
             <a:r>
               <a:rPr lang="en-US" dirty="0"/>
-              <a:t/>
+              <a:t>Give the audience room for points they prepared in advance. If nobody starts, ask who noted a criticism we did not cover.</a:t>
             </a:r>
             <a:endParaRPr lang="en-US" dirty="0"/>
           </a:p>
@@ -2732,6 +2734,94 @@
             <a:fld id="{F7021451-1387-4CA6-816F-3879F97B5CBC}" type="slidenum">
               <a:rPr lang="en-US"/>
               <a:t>31</a:t>
+            </a:fld>
+            <a:endParaRPr lang="en-US"/>
+          </a:p>
+        </p:txBody>
+      </p:sp>
+    </p:spTree>
+    <p:extLst>
+      <p:ext uri="{BB962C8B-B14F-4D97-AF65-F5344CB8AC3E}">
+        <p14:creationId xmlns:p14="http://schemas.microsoft.com/office/powerpoint/2010/main" val="1024086991"/>
+      </p:ext>
+    </p:extLst>
+  </p:cSld>
+  <p:clrMapOvr>
+    <a:masterClrMapping/>
+  </p:clrMapOvr>
+</p:notes>
+</file>
+
+<file path=ppt/notesSlides/notesSlide32.xml><?xml version="1.0" encoding="utf-8"?>
+<p:notes xmlns:a="http://schemas.openxmlformats.org/drawingml/2006/main" xmlns:r="http://schemas.openxmlformats.org/officeDocument/2006/relationships" xmlns:p="http://schemas.openxmlformats.org/presentationml/2006/main">
+  <p:cSld>
+    <p:spTree>
+      <p:nvGrpSpPr>
+        <p:cNvPr id="1" name=""/>
+        <p:cNvGrpSpPr/>
+        <p:nvPr/>
+      </p:nvGrpSpPr>
+      <p:grpSpPr>
+        <a:xfrm>
+          <a:off x="0" y="0"/>
+          <a:ext cx="0" cy="0"/>
+          <a:chOff x="0" y="0"/>
+          <a:chExt cx="0" cy="0"/>
+        </a:xfrm>
+      </p:grpSpPr>
+      <p:sp>
+        <p:nvSpPr>
+          <p:cNvPr id="2" name="Slide Image Placeholder 1"/>
+          <p:cNvSpPr>
+            <a:spLocks noGrp="1" noRot="1" noChangeAspect="1"/>
+          </p:cNvSpPr>
+          <p:nvPr>
+            <p:ph type="sldImg"/>
+          </p:nvPr>
+        </p:nvSpPr>
+        <p:spPr/>
+      </p:sp>
+      <p:sp>
+        <p:nvSpPr>
+          <p:cNvPr id="3" name="Notes Placeholder 2"/>
+          <p:cNvSpPr>
+            <a:spLocks noGrp="1"/>
+          </p:cNvSpPr>
+          <p:nvPr>
+            <p:ph type="body" idx="1"/>
+          </p:nvPr>
+        </p:nvSpPr>
+        <p:spPr/>
+        <p:txBody>
+          <a:bodyPr/>
+          <a:lstStyle/>
+          <a:p>
+            <a:r>
+              <a:rPr lang="en-US" dirty="0"/>
+              <a:t/>
+            </a:r>
+            <a:endParaRPr lang="en-US" dirty="0"/>
+          </a:p>
+        </p:txBody>
+      </p:sp>
+      <p:sp>
+        <p:nvSpPr>
+          <p:cNvPr id="4" name="Slide Number Placeholder 3"/>
+          <p:cNvSpPr>
+            <a:spLocks noGrp="1"/>
+          </p:cNvSpPr>
+          <p:nvPr>
+            <p:ph type="sldNum" sz="quarter" idx="10"/>
+          </p:nvPr>
+        </p:nvSpPr>
+        <p:spPr/>
+        <p:txBody>
+          <a:bodyPr/>
+          <a:lstStyle/>
+          <a:p>
+            <a:fld id="{F7021451-1387-4CA6-816F-3879F97B5CBC}" type="slidenum">
+              <a:rPr lang="en-US"/>
+              <a:t>32</a:t>
             </a:fld>
             <a:endParaRPr lang="en-US"/>
           </a:p>
@@ -11940,6 +12030,224 @@
         </p:nvSpPr>
         <p:spPr>
           <a:xfrm>
+            <a:off x="640080" y="365760"/>
+            <a:ext cx="10911535" cy="822960"/>
+          </a:xfrm>
+          <a:prstGeom prst="rect">
+            <a:avLst/>
+          </a:prstGeom>
+          <a:noFill/>
+          <a:ln/>
+        </p:spPr>
+        <p:txBody>
+          <a:bodyPr wrap="square" lIns="0" tIns="0" rIns="0" bIns="0" rtlCol="0" anchor="ctr"/>
+          <a:lstStyle/>
+          <a:p>
+            <a:pPr indent="0" marL="0">
+              <a:buNone/>
+            </a:pPr>
+            <a:r>
+              <a:rPr lang="en-US" sz="4000" b="1" dirty="0">
+                <a:solidFill>
+                  <a:srgbClr val="00883A"/>
+                </a:solidFill>
+                <a:latin typeface="Arial" pitchFamily="34" charset="0"/>
+                <a:ea typeface="Arial" pitchFamily="34" charset="-122"/>
+                <a:cs typeface="Arial" pitchFamily="34" charset="-120"/>
+              </a:rPr>
+              <a:t>Open Floor</a:t>
+            </a:r>
+            <a:endParaRPr lang="en-US" sz="4000" dirty="0"/>
+          </a:p>
+        </p:txBody>
+      </p:sp>
+      <p:sp>
+        <p:nvSpPr>
+          <p:cNvPr id="3" name="Text 1"/>
+          <p:cNvSpPr txBox="1"/>
+          <p:nvPr/>
+        </p:nvSpPr>
+        <p:spPr>
+          <a:xfrm>
+            <a:off x="640080" y="1463040"/>
+            <a:ext cx="10911535" cy="4754880"/>
+          </a:xfrm>
+          <a:prstGeom prst="rect">
+            <a:avLst/>
+          </a:prstGeom>
+          <a:noFill/>
+          <a:ln/>
+        </p:spPr>
+        <p:txBody>
+          <a:bodyPr wrap="square" lIns="0" tIns="0" rIns="0" bIns="0" rtlCol="0" anchor="t"/>
+          <a:lstStyle/>
+          <a:p>
+            <a:pPr marL="279400" indent="-279400">
+              <a:spcAft>
+                <a:spcPts val="1000"/>
+              </a:spcAft>
+              <a:buSzPct val="100000"/>
+              <a:buChar char="•"/>
+            </a:pPr>
+            <a:r>
+              <a:rPr lang="en-US" sz="2200" dirty="0">
+                <a:solidFill>
+                  <a:srgbClr val="1A1A1A"/>
+                </a:solidFill>
+                <a:latin typeface="Arial" pitchFamily="34" charset="0"/>
+                <a:ea typeface="Arial" pitchFamily="34" charset="-122"/>
+                <a:cs typeface="Arial" pitchFamily="34" charset="-120"/>
+              </a:rPr>
+              <a:t>Any further discussion points you wanted to bring up?</a:t>
+            </a:r>
+            <a:endParaRPr lang="en-US" sz="2200" dirty="0"/>
+          </a:p>
+          <a:p>
+            <a:pPr marL="279400" indent="-279400">
+              <a:spcAft>
+                <a:spcPts val="1000"/>
+              </a:spcAft>
+              <a:buSzPct val="100000"/>
+              <a:buChar char="•"/>
+            </a:pPr>
+            <a:r>
+              <a:rPr lang="en-US" sz="2200" dirty="0">
+                <a:solidFill>
+                  <a:srgbClr val="1A1A1A"/>
+                </a:solidFill>
+                <a:latin typeface="Arial" pitchFamily="34" charset="0"/>
+                <a:ea typeface="Arial" pitchFamily="34" charset="-122"/>
+                <a:cs typeface="Arial" pitchFamily="34" charset="-120"/>
+              </a:rPr>
+              <a:t>Criticisms of either paper we have not covered</a:t>
+            </a:r>
+            <a:endParaRPr lang="en-US" sz="2200" dirty="0"/>
+          </a:p>
+          <a:p>
+            <a:pPr marL="279400" indent="-279400">
+              <a:spcAft>
+                <a:spcPts val="1000"/>
+              </a:spcAft>
+              <a:buSzPct val="100000"/>
+              <a:buChar char="•"/>
+            </a:pPr>
+            <a:r>
+              <a:rPr lang="en-US" sz="2200" dirty="0">
+                <a:solidFill>
+                  <a:srgbClr val="1A1A1A"/>
+                </a:solidFill>
+                <a:latin typeface="Arial" pitchFamily="34" charset="0"/>
+                <a:ea typeface="Arial" pitchFamily="34" charset="-122"/>
+                <a:cs typeface="Arial" pitchFamily="34" charset="-120"/>
+              </a:rPr>
+              <a:t>Further interesting ideas or approaches you want to talk about</a:t>
+            </a:r>
+            <a:endParaRPr lang="en-US" sz="2200" dirty="0"/>
+          </a:p>
+          <a:p>
+            <a:pPr marL="279400" indent="-279400">
+              <a:spcAft>
+                <a:spcPts val="1000"/>
+              </a:spcAft>
+              <a:buSzPct val="100000"/>
+              <a:buChar char="•"/>
+            </a:pPr>
+            <a:r>
+              <a:rPr lang="en-US" sz="2200" dirty="0">
+                <a:solidFill>
+                  <a:srgbClr val="1A1A1A"/>
+                </a:solidFill>
+                <a:latin typeface="Arial" pitchFamily="34" charset="0"/>
+                <a:ea typeface="Arial" pitchFamily="34" charset="-122"/>
+                <a:cs typeface="Arial" pitchFamily="34" charset="-120"/>
+              </a:rPr>
+              <a:t>Anything from your own notes and preparation</a:t>
+            </a:r>
+            <a:endParaRPr lang="en-US" sz="2200" dirty="0"/>
+          </a:p>
+        </p:txBody>
+      </p:sp>
+      <p:sp>
+        <p:nvSpPr>
+          <p:cNvPr id="25" name="Slide Number Placeholder 0"/>
+          <p:cNvSpPr>
+            <a:spLocks noGrp="1"/>
+          </p:cNvSpPr>
+          <p:nvPr>
+            <p:ph type="sldNum" sz="quarter" idx="4294967295"/>
+          </p:nvPr>
+        </p:nvSpPr>
+        <p:spPr>
+          <a:xfrm>
+            <a:off x="11247120" y="6355080"/>
+            <a:ext cx="548640" cy="320040"/>
+          </a:xfrm>
+          <a:prstGeom prst="rect">
+            <a:avLst/>
+          </a:prstGeom>
+          <a:extLst>
+            <a:ext uri="{C572A759-6A51-4108-AA02-DFA0A04FC94B}">
+              <ma14:wrappingTextBoxFlag xmlns:ma14="http://schemas.microsoft.com/office/mac/drawingml/2011/main" val="0"/>
+            </a:ext>
+          </a:extLst>
+        </p:spPr>
+        <p:txBody>
+          <a:bodyPr/>
+          <a:lstStyle>
+            <a:lvl1pPr>
+              <a:defRPr sz="1100">
+                <a:solidFill>
+                  <a:srgbClr val="5F6368"/>
+                </a:solidFill>
+                <a:latin typeface="Arial"/>
+                <a:ea typeface="Arial"/>
+                <a:cs typeface="Arial"/>
+              </a:defRPr>
+            </a:lvl1pPr>
+          </a:lstStyle>
+          <a:p>
+            <a:pPr algn="l"/>
+            <a:fld id="{F7021451-1387-4CA6-816F-3879F97B5CBC}" type="slidenum">
+              <a:rPr b="0" lang="en-US"/>
+              <a:t>31</a:t>
+            </a:fld>
+            <a:endParaRPr lang="en-US"/>
+          </a:p>
+        </p:txBody>
+      </p:sp>
+    </p:spTree>
+  </p:cSld>
+  <p:clrMapOvr>
+    <a:masterClrMapping/>
+  </p:clrMapOvr>
+</p:sld>
+</file>
+
+<file path=ppt/slides/slide32.xml><?xml version="1.0" encoding="utf-8"?>
+<p:sld xmlns:a="http://schemas.openxmlformats.org/drawingml/2006/main" xmlns:r="http://schemas.openxmlformats.org/officeDocument/2006/relationships" xmlns:p="http://schemas.openxmlformats.org/presentationml/2006/main">
+  <p:cSld name="Slide 32">
+    <p:spTree>
+      <p:nvGrpSpPr>
+        <p:cNvPr id="1" name=""/>
+        <p:cNvGrpSpPr/>
+        <p:nvPr/>
+      </p:nvGrpSpPr>
+      <p:grpSpPr>
+        <a:xfrm>
+          <a:off x="0" y="0"/>
+          <a:ext cx="0" cy="0"/>
+          <a:chOff x="0" y="0"/>
+          <a:chExt cx="0" cy="0"/>
+        </a:xfrm>
+      </p:grpSpPr>
+      <p:sp>
+        <p:nvSpPr>
+          <p:cNvPr id="2" name="Text 0"/>
+          <p:cNvSpPr txBox="1"/>
+          <p:nvPr/>
+        </p:nvSpPr>
+        <p:spPr>
+          <a:xfrm>
             <a:off x="640080" y="2560320"/>
             <a:ext cx="10911535" cy="1371600"/>
           </a:xfrm>

</xml_diff>